<commit_message>
added text to prezentation
</commit_message>
<xml_diff>
--- a/Томчук А.С. Презентация.pptx
+++ b/Томчук А.С. Презентация.pptx
@@ -298,7 +298,7 @@
           <a:p>
             <a:fld id="{8222D90B-614B-4BEA-AF73-760DACBB3A61}" type="datetimeFigureOut">
               <a:rPr lang="ru-RU" smtClean="0"/>
-              <a:t>28.01.2026</a:t>
+              <a:t>29.01.2026</a:t>
             </a:fld>
             <a:endParaRPr lang="ru-RU"/>
           </a:p>
@@ -749,7 +749,7 @@
             <a:fld id="{E6618210-AA3C-4E5C-8A8F-AA37F5428033}" type="datetimeFigureOut">
               <a:rPr lang="ru-RU" smtClean="0"/>
               <a:pPr/>
-              <a:t>28.01.2026</a:t>
+              <a:t>29.01.2026</a:t>
             </a:fld>
             <a:endParaRPr lang="ru-RU"/>
           </a:p>
@@ -980,7 +980,7 @@
           <a:p>
             <a:fld id="{E6618210-AA3C-4E5C-8A8F-AA37F5428033}" type="datetimeFigureOut">
               <a:rPr lang="ru-RU" smtClean="0"/>
-              <a:t>28.01.2026</a:t>
+              <a:t>29.01.2026</a:t>
             </a:fld>
             <a:endParaRPr lang="ru-RU"/>
           </a:p>
@@ -1200,7 +1200,7 @@
           <a:p>
             <a:fld id="{E6618210-AA3C-4E5C-8A8F-AA37F5428033}" type="datetimeFigureOut">
               <a:rPr lang="ru-RU" smtClean="0"/>
-              <a:t>28.01.2026</a:t>
+              <a:t>29.01.2026</a:t>
             </a:fld>
             <a:endParaRPr lang="ru-RU"/>
           </a:p>
@@ -2589,7 +2589,7 @@
           <a:p>
             <a:fld id="{E6618210-AA3C-4E5C-8A8F-AA37F5428033}" type="datetimeFigureOut">
               <a:rPr lang="ru-RU" smtClean="0"/>
-              <a:t>28.01.2026</a:t>
+              <a:t>29.01.2026</a:t>
             </a:fld>
             <a:endParaRPr lang="ru-RU"/>
           </a:p>
@@ -2876,7 +2876,7 @@
           <a:p>
             <a:fld id="{E6618210-AA3C-4E5C-8A8F-AA37F5428033}" type="datetimeFigureOut">
               <a:rPr lang="ru-RU" smtClean="0"/>
-              <a:t>28.01.2026</a:t>
+              <a:t>29.01.2026</a:t>
             </a:fld>
             <a:endParaRPr lang="ru-RU"/>
           </a:p>
@@ -3153,7 +3153,7 @@
           <a:p>
             <a:fld id="{E6618210-AA3C-4E5C-8A8F-AA37F5428033}" type="datetimeFigureOut">
               <a:rPr lang="ru-RU" smtClean="0"/>
-              <a:t>28.01.2026</a:t>
+              <a:t>29.01.2026</a:t>
             </a:fld>
             <a:endParaRPr lang="ru-RU"/>
           </a:p>
@@ -3577,7 +3577,7 @@
           <a:p>
             <a:fld id="{E6618210-AA3C-4E5C-8A8F-AA37F5428033}" type="datetimeFigureOut">
               <a:rPr lang="ru-RU" smtClean="0"/>
-              <a:t>28.01.2026</a:t>
+              <a:t>29.01.2026</a:t>
             </a:fld>
             <a:endParaRPr lang="ru-RU"/>
           </a:p>
@@ -3730,7 +3730,7 @@
           <a:p>
             <a:fld id="{E6618210-AA3C-4E5C-8A8F-AA37F5428033}" type="datetimeFigureOut">
               <a:rPr lang="ru-RU" smtClean="0"/>
-              <a:t>28.01.2026</a:t>
+              <a:t>29.01.2026</a:t>
             </a:fld>
             <a:endParaRPr lang="ru-RU"/>
           </a:p>
@@ -3855,7 +3855,7 @@
           <a:p>
             <a:fld id="{E6618210-AA3C-4E5C-8A8F-AA37F5428033}" type="datetimeFigureOut">
               <a:rPr lang="ru-RU" smtClean="0"/>
-              <a:t>28.01.2026</a:t>
+              <a:t>29.01.2026</a:t>
             </a:fld>
             <a:endParaRPr lang="ru-RU"/>
           </a:p>
@@ -4178,7 +4178,7 @@
           <a:p>
             <a:fld id="{E6618210-AA3C-4E5C-8A8F-AA37F5428033}" type="datetimeFigureOut">
               <a:rPr lang="ru-RU" smtClean="0"/>
-              <a:t>28.01.2026</a:t>
+              <a:t>29.01.2026</a:t>
             </a:fld>
             <a:endParaRPr lang="ru-RU"/>
           </a:p>
@@ -4478,7 +4478,7 @@
           <a:p>
             <a:fld id="{E6618210-AA3C-4E5C-8A8F-AA37F5428033}" type="datetimeFigureOut">
               <a:rPr lang="ru-RU" smtClean="0"/>
-              <a:t>28.01.2026</a:t>
+              <a:t>29.01.2026</a:t>
             </a:fld>
             <a:endParaRPr lang="ru-RU"/>
           </a:p>
@@ -4731,7 +4731,7 @@
           <a:p>
             <a:fld id="{E6618210-AA3C-4E5C-8A8F-AA37F5428033}" type="datetimeFigureOut">
               <a:rPr lang="ru-RU" smtClean="0"/>
-              <a:t>28.01.2026</a:t>
+              <a:t>29.01.2026</a:t>
             </a:fld>
             <a:endParaRPr lang="ru-RU"/>
           </a:p>
@@ -5670,13 +5670,13 @@
   <p:clrMapOvr>
     <a:masterClrMapping/>
   </p:clrMapOvr>
-  <mc:AlternateContent xmlns:mc="http://schemas.openxmlformats.org/markup-compatibility/2006">
-    <mc:Choice xmlns:p14="http://schemas.microsoft.com/office/powerpoint/2010/main" Requires="p14">
+  <mc:AlternateContent xmlns:mc="http://schemas.openxmlformats.org/markup-compatibility/2006" xmlns:p14="http://schemas.microsoft.com/office/powerpoint/2010/main">
+    <mc:Choice Requires="p14">
       <p:transition spd="med" p14:dur="700">
         <p:fade/>
       </p:transition>
     </mc:Choice>
-    <mc:Fallback>
+    <mc:Fallback xmlns="">
       <p:transition spd="med">
         <p:fade/>
       </p:transition>
@@ -6903,7 +6903,7 @@
                 <a:ea typeface="Times New Roman" panose="02020603050405020304" pitchFamily="18" charset="0"/>
                 <a:cs typeface="Times New Roman" panose="02020603050405020304" pitchFamily="18" charset="0"/>
               </a:rPr>
-              <a:t>10 805,93 руб.</a:t>
+              <a:t>27855,04 руб.</a:t>
             </a:r>
             <a:endParaRPr lang="en-US" sz="2800" dirty="0">
               <a:latin typeface="Times New Roman" panose="02020603050405020304" pitchFamily="18" charset="0"/>
@@ -7076,8 +7076,8 @@
         </p:nvSpPr>
         <p:spPr>
           <a:xfrm>
-            <a:off x="424865" y="1603515"/>
-            <a:ext cx="11342270" cy="4832092"/>
+            <a:off x="920004" y="1897429"/>
+            <a:ext cx="10351992" cy="3785652"/>
           </a:xfrm>
           <a:prstGeom prst="rect">
             <a:avLst/>
@@ -7092,7 +7092,7 @@
           <a:p>
             <a:pPr indent="457200" algn="just"/>
             <a:r>
-              <a:rPr lang="ru-RU" sz="2800" dirty="0">
+              <a:rPr lang="ru-RU" sz="2400" dirty="0">
                 <a:latin typeface="Times New Roman" panose="02020603050405020304" pitchFamily="18" charset="0"/>
                 <a:cs typeface="Times New Roman" panose="02020603050405020304" pitchFamily="18" charset="0"/>
               </a:rPr>
@@ -7102,7 +7102,7 @@
           <a:p>
             <a:pPr indent="457200" algn="just"/>
             <a:r>
-              <a:rPr lang="ru-RU" sz="2800" dirty="0">
+              <a:rPr lang="ru-RU" sz="2400" dirty="0">
                 <a:latin typeface="Times New Roman" panose="02020603050405020304" pitchFamily="18" charset="0"/>
                 <a:cs typeface="Times New Roman" panose="02020603050405020304" pitchFamily="18" charset="0"/>
               </a:rPr>
@@ -7112,13 +7112,13 @@
           <a:p>
             <a:pPr indent="457200" algn="just"/>
             <a:r>
-              <a:rPr lang="ru-RU" sz="2800" dirty="0">
+              <a:rPr lang="ru-RU" sz="2400" dirty="0">
                 <a:latin typeface="Times New Roman" panose="02020603050405020304" pitchFamily="18" charset="0"/>
                 <a:cs typeface="Times New Roman" panose="02020603050405020304" pitchFamily="18" charset="0"/>
               </a:rPr>
               <a:t>Практическая ценность проекта заключается в создании современного, надёжного и простого инструмента для ведения личного бюджета. Приложение может использоваться широкой аудиторией для контроля расходов, анализа финансовых привычек и планирования бюджета.</a:t>
             </a:r>
-            <a:endParaRPr lang="en-BY" sz="2800" dirty="0">
+            <a:endParaRPr lang="en-BY" sz="2400" dirty="0">
               <a:latin typeface="Times New Roman" panose="02020603050405020304" pitchFamily="18" charset="0"/>
               <a:cs typeface="Times New Roman" panose="02020603050405020304" pitchFamily="18" charset="0"/>
             </a:endParaRPr>
@@ -7849,13 +7849,13 @@
   <p:clrMapOvr>
     <a:masterClrMapping/>
   </p:clrMapOvr>
-  <mc:AlternateContent xmlns:mc="http://schemas.openxmlformats.org/markup-compatibility/2006">
-    <mc:Choice xmlns:p14="http://schemas.microsoft.com/office/powerpoint/2010/main" Requires="p14">
+  <mc:AlternateContent xmlns:mc="http://schemas.openxmlformats.org/markup-compatibility/2006" xmlns:p14="http://schemas.microsoft.com/office/powerpoint/2010/main">
+    <mc:Choice Requires="p14">
       <p:transition spd="med" p14:dur="700">
         <p:fade/>
       </p:transition>
     </mc:Choice>
-    <mc:Fallback>
+    <mc:Fallback xmlns="">
       <p:transition spd="med">
         <p:fade/>
       </p:transition>
@@ -7958,73 +7958,6 @@
                 <a:cs typeface="Times New Roman" panose="02020603050405020304" pitchFamily="18" charset="0"/>
               </a:rPr>
               <a:t>дипломного проекта</a:t>
-            </a:r>
-          </a:p>
-        </p:txBody>
-      </p:sp>
-      <p:sp>
-        <p:nvSpPr>
-          <p:cNvPr id="3" name="Подзаголовок 2">
-            <a:extLst>
-              <a:ext uri="{FF2B5EF4-FFF2-40B4-BE49-F238E27FC236}">
-                <a16:creationId xmlns:a16="http://schemas.microsoft.com/office/drawing/2014/main" id="{BA665B7B-0119-40E8-95F7-F4406F91975C}"/>
-              </a:ext>
-            </a:extLst>
-          </p:cNvPr>
-          <p:cNvSpPr>
-            <a:spLocks noGrp="1"/>
-          </p:cNvSpPr>
-          <p:nvPr>
-            <p:ph type="subTitle" idx="1"/>
-          </p:nvPr>
-        </p:nvSpPr>
-        <p:spPr>
-          <a:xfrm>
-            <a:off x="181319" y="1528319"/>
-            <a:ext cx="6642550" cy="2085036"/>
-          </a:xfrm>
-        </p:spPr>
-        <p:txBody>
-          <a:bodyPr>
-            <a:noAutofit/>
-          </a:bodyPr>
-          <a:lstStyle/>
-          <a:p>
-            <a:pPr indent="457200" algn="just">
-              <a:lnSpc>
-                <a:spcPct val="110000"/>
-              </a:lnSpc>
-              <a:spcBef>
-                <a:spcPts val="0"/>
-              </a:spcBef>
-            </a:pPr>
-            <a:r>
-              <a:rPr lang="ru-RU" sz="2000" dirty="0">
-                <a:latin typeface="Times New Roman" panose="02020603050405020304" pitchFamily="18" charset="0"/>
-                <a:cs typeface="Times New Roman" panose="02020603050405020304" pitchFamily="18" charset="0"/>
-              </a:rPr>
-              <a:t>Цель дипломного проекта  </a:t>
-            </a:r>
-            <a:r>
-              <a:rPr lang="ru-RU" sz="2000" b="0" dirty="0">
-                <a:latin typeface="Times New Roman" panose="02020603050405020304" pitchFamily="18" charset="0"/>
-                <a:cs typeface="Times New Roman" panose="02020603050405020304" pitchFamily="18" charset="0"/>
-              </a:rPr>
-              <a:t>–</a:t>
-            </a:r>
-            <a:r>
-              <a:rPr lang="en-US" sz="2000" b="0" dirty="0">
-                <a:latin typeface="Times New Roman" panose="02020603050405020304" pitchFamily="18" charset="0"/>
-                <a:cs typeface="Times New Roman" panose="02020603050405020304" pitchFamily="18" charset="0"/>
-              </a:rPr>
-              <a:t> </a:t>
-            </a:r>
-            <a:r>
-              <a:rPr lang="ru-RU" sz="2000" b="0" dirty="0">
-                <a:latin typeface="Times New Roman" panose="02020603050405020304" pitchFamily="18" charset="0"/>
-                <a:cs typeface="Times New Roman" panose="02020603050405020304" pitchFamily="18" charset="0"/>
-              </a:rPr>
-              <a:t>разработка кроссплатформенного мобильного приложения для учёта и анализа персональных расходов, обеспечивающего интуитивно понятный интерфейс с применением современных архитектурных и технологических решений. </a:t>
             </a:r>
           </a:p>
         </p:txBody>
@@ -8438,6 +8371,73 @@
           </a:p>
         </p:txBody>
       </p:sp>
+      <p:sp>
+        <p:nvSpPr>
+          <p:cNvPr id="3" name="Подзаголовок 2">
+            <a:extLst>
+              <a:ext uri="{FF2B5EF4-FFF2-40B4-BE49-F238E27FC236}">
+                <a16:creationId xmlns:a16="http://schemas.microsoft.com/office/drawing/2014/main" id="{BA665B7B-0119-40E8-95F7-F4406F91975C}"/>
+              </a:ext>
+            </a:extLst>
+          </p:cNvPr>
+          <p:cNvSpPr>
+            <a:spLocks noGrp="1"/>
+          </p:cNvSpPr>
+          <p:nvPr>
+            <p:ph type="subTitle" idx="1"/>
+          </p:nvPr>
+        </p:nvSpPr>
+        <p:spPr>
+          <a:xfrm>
+            <a:off x="181319" y="1528319"/>
+            <a:ext cx="6642550" cy="2085036"/>
+          </a:xfrm>
+        </p:spPr>
+        <p:txBody>
+          <a:bodyPr>
+            <a:noAutofit/>
+          </a:bodyPr>
+          <a:lstStyle/>
+          <a:p>
+            <a:pPr indent="457200" algn="just">
+              <a:lnSpc>
+                <a:spcPct val="110000"/>
+              </a:lnSpc>
+              <a:spcBef>
+                <a:spcPts val="0"/>
+              </a:spcBef>
+            </a:pPr>
+            <a:r>
+              <a:rPr lang="ru-RU" sz="2000" dirty="0">
+                <a:latin typeface="Times New Roman" panose="02020603050405020304" pitchFamily="18" charset="0"/>
+                <a:cs typeface="Times New Roman" panose="02020603050405020304" pitchFamily="18" charset="0"/>
+              </a:rPr>
+              <a:t>Цель дипломного проекта  </a:t>
+            </a:r>
+            <a:r>
+              <a:rPr lang="ru-RU" sz="2000" b="0" dirty="0">
+                <a:latin typeface="Times New Roman" panose="02020603050405020304" pitchFamily="18" charset="0"/>
+                <a:cs typeface="Times New Roman" panose="02020603050405020304" pitchFamily="18" charset="0"/>
+              </a:rPr>
+              <a:t>–</a:t>
+            </a:r>
+            <a:r>
+              <a:rPr lang="en-US" sz="2000" b="0" dirty="0">
+                <a:latin typeface="Times New Roman" panose="02020603050405020304" pitchFamily="18" charset="0"/>
+                <a:cs typeface="Times New Roman" panose="02020603050405020304" pitchFamily="18" charset="0"/>
+              </a:rPr>
+              <a:t> </a:t>
+            </a:r>
+            <a:r>
+              <a:rPr lang="ru-RU" sz="2000" b="0" dirty="0">
+                <a:latin typeface="Times New Roman" panose="02020603050405020304" pitchFamily="18" charset="0"/>
+                <a:cs typeface="Times New Roman" panose="02020603050405020304" pitchFamily="18" charset="0"/>
+              </a:rPr>
+              <a:t>разработка кроссплатформенного мобильного приложения для учёта и анализа персональных расходов, обеспечивающего интуитивно понятный интерфейс с применением современных архитектурных и технологических решений. </a:t>
+            </a:r>
+          </a:p>
+        </p:txBody>
+      </p:sp>
     </p:spTree>
     <p:extLst>
       <p:ext uri="{BB962C8B-B14F-4D97-AF65-F5344CB8AC3E}">
@@ -8543,6 +8543,9 @@
           <a:lstStyle/>
           <a:p>
             <a:pPr algn="just">
+              <a:lnSpc>
+                <a:spcPct val="100000"/>
+              </a:lnSpc>
               <a:buNone/>
             </a:pPr>
             <a:r>
@@ -8550,7 +8553,7 @@
                 <a:latin typeface="Times New Roman" panose="02020603050405020304" pitchFamily="18" charset="0"/>
                 <a:cs typeface="Times New Roman" panose="02020603050405020304" pitchFamily="18" charset="0"/>
               </a:rPr>
-              <a:t>Актуальность разработки</a:t>
+              <a:t>Актуальность разработки:</a:t>
             </a:r>
           </a:p>
           <a:p>
@@ -8569,6 +8572,25 @@
                 <a:latin typeface="Times New Roman" panose="02020603050405020304" pitchFamily="18" charset="0"/>
                 <a:cs typeface="Times New Roman" panose="02020603050405020304" pitchFamily="18" charset="0"/>
               </a:rPr>
+              <a:t>отсутствие у пользователей системного контроля бюджета;</a:t>
+            </a:r>
+          </a:p>
+          <a:p>
+            <a:pPr marL="0" indent="457200" algn="just">
+              <a:lnSpc>
+                <a:spcPct val="100000"/>
+              </a:lnSpc>
+              <a:spcBef>
+                <a:spcPts val="0"/>
+              </a:spcBef>
+              <a:buFont typeface="Arial" panose="020B0604020202020204" pitchFamily="34" charset="0"/>
+              <a:buChar char="–"/>
+            </a:pPr>
+            <a:r>
+              <a:rPr lang="ru-RU" sz="2400" dirty="0">
+                <a:latin typeface="Times New Roman" panose="02020603050405020304" pitchFamily="18" charset="0"/>
+                <a:cs typeface="Times New Roman" panose="02020603050405020304" pitchFamily="18" charset="0"/>
+              </a:rPr>
               <a:t>разрозненность существующих процессов и отсутствием единой универсальной системы менеджмента бюджета;</a:t>
             </a:r>
           </a:p>
@@ -8585,7 +8607,7 @@
                 <a:latin typeface="Times New Roman" panose="02020603050405020304" pitchFamily="18" charset="0"/>
                 <a:cs typeface="Times New Roman" panose="02020603050405020304" pitchFamily="18" charset="0"/>
               </a:rPr>
-              <a:t>отсутствие у пользователей системного контроля бюджета;</a:t>
+              <a:t>необходимость наглядного анализа расходов и доходов;</a:t>
             </a:r>
           </a:p>
           <a:p>
@@ -8601,23 +8623,7 @@
                 <a:latin typeface="Times New Roman" panose="02020603050405020304" pitchFamily="18" charset="0"/>
                 <a:cs typeface="Times New Roman" panose="02020603050405020304" pitchFamily="18" charset="0"/>
               </a:rPr>
-              <a:t>необходимость наглядного анализа расходов и доходов;</a:t>
-            </a:r>
-          </a:p>
-          <a:p>
-            <a:pPr marL="0" indent="457200" algn="just">
-              <a:lnSpc>
-                <a:spcPct val="100000"/>
-              </a:lnSpc>
-              <a:buFont typeface="Arial" panose="020B0604020202020204" pitchFamily="34" charset="0"/>
-              <a:buChar char="–"/>
-            </a:pPr>
-            <a:r>
-              <a:rPr lang="ru-RU" sz="2400" dirty="0">
-                <a:latin typeface="Times New Roman" panose="02020603050405020304" pitchFamily="18" charset="0"/>
-                <a:cs typeface="Times New Roman" panose="02020603050405020304" pitchFamily="18" charset="0"/>
-              </a:rPr>
-              <a:t>востребованность цифровых инструментов финансового планирования</a:t>
+              <a:t>востребованность цифровых инструментов финансового планирования.</a:t>
             </a:r>
           </a:p>
           <a:p>
@@ -8769,8 +8775,8 @@
         </p:nvSpPr>
         <p:spPr>
           <a:xfrm>
-            <a:off x="231720" y="1442546"/>
-            <a:ext cx="11728560" cy="5268937"/>
+            <a:off x="622045" y="1671147"/>
+            <a:ext cx="10947909" cy="4615354"/>
           </a:xfrm>
         </p:spPr>
         <p:txBody>
@@ -8794,7 +8800,7 @@
                 <a:latin typeface="Times New Roman" panose="02020603050405020304" pitchFamily="18" charset="0"/>
                 <a:cs typeface="Times New Roman" panose="02020603050405020304" pitchFamily="18" charset="0"/>
               </a:rPr>
-              <a:t>добавление, редактирование и удаление записей о доходах и расходах с возможностью выбора категории, даты и валюты; </a:t>
+              <a:t>управление транзакциями с возможностью выбора категории, даты и валюты; </a:t>
             </a:r>
           </a:p>
           <a:p>
@@ -8813,7 +8819,7 @@
                 <a:latin typeface="Times New Roman" panose="02020603050405020304" pitchFamily="18" charset="0"/>
                 <a:cs typeface="Times New Roman" panose="02020603050405020304" pitchFamily="18" charset="0"/>
               </a:rPr>
-              <a:t>отображение финансовых операций в виде списка с возможностью фильтрации по дате, категории или типу операции;</a:t>
+              <a:t>отображение финансовых операций в виде списка с возможностью фильтрации по дате, категории или типу операции; </a:t>
             </a:r>
           </a:p>
           <a:p>
@@ -8832,7 +8838,7 @@
                 <a:latin typeface="Times New Roman" panose="02020603050405020304" pitchFamily="18" charset="0"/>
                 <a:cs typeface="Times New Roman" panose="02020603050405020304" pitchFamily="18" charset="0"/>
               </a:rPr>
-              <a:t>ведение учёта в нескольких; </a:t>
+              <a:t>настройка бюджета с указанием лимита на определённый период и уведомления при его превышении;</a:t>
             </a:r>
           </a:p>
           <a:p>
@@ -8851,7 +8857,21 @@
                 <a:latin typeface="Times New Roman" panose="02020603050405020304" pitchFamily="18" charset="0"/>
                 <a:cs typeface="Times New Roman" panose="02020603050405020304" pitchFamily="18" charset="0"/>
               </a:rPr>
-              <a:t>настройка индивидуального бюджета с указанием лимита на определённый период и уведомления при его превышении;</a:t>
+              <a:t>авторизация пользователя PIN-кода или биометрической аутентификации (Face/Touch </a:t>
+            </a:r>
+            <a:r>
+              <a:rPr lang="ru-RU" sz="2400" dirty="0" err="1">
+                <a:latin typeface="Times New Roman" panose="02020603050405020304" pitchFamily="18" charset="0"/>
+                <a:cs typeface="Times New Roman" panose="02020603050405020304" pitchFamily="18" charset="0"/>
+              </a:rPr>
+              <a:t>id</a:t>
+            </a:r>
+            <a:r>
+              <a:rPr lang="ru-RU" sz="2400" dirty="0">
+                <a:latin typeface="Times New Roman" panose="02020603050405020304" pitchFamily="18" charset="0"/>
+                <a:cs typeface="Times New Roman" panose="02020603050405020304" pitchFamily="18" charset="0"/>
+              </a:rPr>
+              <a:t>);</a:t>
             </a:r>
           </a:p>
           <a:p>
@@ -8870,21 +8890,7 @@
                 <a:latin typeface="Times New Roman" panose="02020603050405020304" pitchFamily="18" charset="0"/>
                 <a:cs typeface="Times New Roman" panose="02020603050405020304" pitchFamily="18" charset="0"/>
               </a:rPr>
-              <a:t>реализация авторизации пользователя PIN-кода или биометрической аутентификации (Face/Touch </a:t>
-            </a:r>
-            <a:r>
-              <a:rPr lang="ru-RU" sz="2400" dirty="0" err="1">
-                <a:latin typeface="Times New Roman" panose="02020603050405020304" pitchFamily="18" charset="0"/>
-                <a:cs typeface="Times New Roman" panose="02020603050405020304" pitchFamily="18" charset="0"/>
-              </a:rPr>
-              <a:t>id</a:t>
-            </a:r>
-            <a:r>
-              <a:rPr lang="ru-RU" sz="2400" dirty="0">
-                <a:latin typeface="Times New Roman" panose="02020603050405020304" pitchFamily="18" charset="0"/>
-                <a:cs typeface="Times New Roman" panose="02020603050405020304" pitchFamily="18" charset="0"/>
-              </a:rPr>
-              <a:t>);</a:t>
+              <a:t>поддержка локализации интерфейса (многоязычный интерфейс);</a:t>
             </a:r>
           </a:p>
           <a:p>
@@ -8903,26 +8909,7 @@
                 <a:latin typeface="Times New Roman" panose="02020603050405020304" pitchFamily="18" charset="0"/>
                 <a:cs typeface="Times New Roman" panose="02020603050405020304" pitchFamily="18" charset="0"/>
               </a:rPr>
-              <a:t>поддержка локализации интерфейса (многоязычный интерфейс);</a:t>
-            </a:r>
-          </a:p>
-          <a:p>
-            <a:pPr marL="0" indent="-457200" algn="just">
-              <a:lnSpc>
-                <a:spcPct val="100000"/>
-              </a:lnSpc>
-              <a:spcBef>
-                <a:spcPts val="0"/>
-              </a:spcBef>
-              <a:buFont typeface="Times New Roman" panose="02020603050405020304" pitchFamily="18" charset="0"/>
-              <a:buChar char="‒"/>
-            </a:pPr>
-            <a:r>
-              <a:rPr lang="ru-RU" sz="2400" dirty="0">
-                <a:latin typeface="Times New Roman" panose="02020603050405020304" pitchFamily="18" charset="0"/>
-                <a:cs typeface="Times New Roman" panose="02020603050405020304" pitchFamily="18" charset="0"/>
-              </a:rPr>
-              <a:t>возможность локального хранения данных с опцией синхронизации и резервного копирования;</a:t>
+              <a:t>локальное хранения данных с опцией синхронизации и резервного копирования;</a:t>
             </a:r>
           </a:p>
           <a:p>
@@ -9366,7 +9353,7 @@
             <p:ph idx="1"/>
             <p:extLst>
               <p:ext uri="{D42A27DB-BD31-4B8C-83A1-F6EECF244321}">
-                <p14:modId xmlns:p14="http://schemas.microsoft.com/office/powerpoint/2010/main" val="391288942"/>
+                <p14:modId xmlns:p14="http://schemas.microsoft.com/office/powerpoint/2010/main" val="1195809498"/>
               </p:ext>
             </p:extLst>
           </p:nvPr>
@@ -9765,7 +9752,7 @@
                           <a:latin typeface="Times New Roman" panose="02020603050405020304" pitchFamily="18" charset="0"/>
                           <a:cs typeface="Times New Roman" panose="02020603050405020304" pitchFamily="18" charset="0"/>
                         </a:rPr>
-                        <a:t> (разрабатываемое приложение)</a:t>
+                        <a:t> (разработанное приложение)</a:t>
                       </a:r>
                       <a:endParaRPr lang="ru-RU" sz="1100" kern="100" dirty="0">
                         <a:solidFill>
@@ -13911,7 +13898,7 @@
                 <a:latin typeface="Times New Roman" panose="02020603050405020304" pitchFamily="18" charset="0"/>
                 <a:cs typeface="Times New Roman" panose="02020603050405020304" pitchFamily="18" charset="0"/>
               </a:rPr>
-              <a:t>Среда разработки: </a:t>
+              <a:t> Среда разработки: </a:t>
             </a:r>
             <a:r>
               <a:rPr lang="en-GB" sz="2400" b="1" dirty="0">
@@ -13935,7 +13922,7 @@
                 <a:latin typeface="Times New Roman" panose="02020603050405020304" pitchFamily="18" charset="0"/>
                 <a:cs typeface="Times New Roman" panose="02020603050405020304" pitchFamily="18" charset="0"/>
               </a:rPr>
-              <a:t>Платформа и язык разработки</a:t>
+              <a:t> Платформа и язык разработки</a:t>
             </a:r>
             <a:r>
               <a:rPr lang="en-GB" sz="2400" dirty="0">
@@ -13973,7 +13960,7 @@
                 <a:latin typeface="Times New Roman" panose="02020603050405020304" pitchFamily="18" charset="0"/>
                 <a:cs typeface="Times New Roman" panose="02020603050405020304" pitchFamily="18" charset="0"/>
               </a:rPr>
-              <a:t>База данных и хранение данных: </a:t>
+              <a:t> База данных и хранение данных: </a:t>
             </a:r>
             <a:r>
               <a:rPr lang="en-US" sz="2400" dirty="0">
@@ -14097,7 +14084,7 @@
         </p:nvSpPr>
         <p:spPr>
           <a:xfrm>
-            <a:off x="664175" y="2802181"/>
+            <a:off x="664175" y="2682977"/>
             <a:ext cx="6866925" cy="3462486"/>
           </a:xfrm>
           <a:prstGeom prst="rect">
@@ -14353,13 +14340,13 @@
   <p:clrMapOvr>
     <a:masterClrMapping/>
   </p:clrMapOvr>
-  <mc:AlternateContent xmlns:mc="http://schemas.openxmlformats.org/markup-compatibility/2006">
-    <mc:Choice xmlns:p14="http://schemas.microsoft.com/office/powerpoint/2010/main" Requires="p14">
+  <mc:AlternateContent xmlns:mc="http://schemas.openxmlformats.org/markup-compatibility/2006" xmlns:p14="http://schemas.microsoft.com/office/powerpoint/2010/main">
+    <mc:Choice Requires="p14">
       <p:transition spd="med" p14:dur="700">
         <p:fade/>
       </p:transition>
     </mc:Choice>
-    <mc:Fallback>
+    <mc:Fallback xmlns="">
       <p:transition spd="med">
         <p:fade/>
       </p:transition>

</xml_diff>